<commit_message>
4th commit in main-added deliverables.
</commit_message>
<xml_diff>
--- a/IAC IP25 - Machine Learning - WBS - Pranay Sunil Jagatp.pptx
+++ b/IAC IP25 - Machine Learning - WBS - Pranay Sunil Jagatp.pptx
@@ -113,12 +113,775 @@
 <file path=ppt/revisionInfo.xml><?xml version="1.0" encoding="utf-8"?>
 <p1510:revInfo xmlns:a="http://schemas.openxmlformats.org/drawingml/2006/main" xmlns:r="http://schemas.openxmlformats.org/officeDocument/2006/relationships" xmlns:p1510="http://schemas.microsoft.com/office/powerpoint/2015/10/main">
   <p1510:revLst>
-    <p1510:client id="{09C77011-8D33-7B85-84CC-6FD0245FF5D8}" v="89" dt="2025-03-11T09:32:39.768"/>
-    <p1510:client id="{1785DEB7-9EA6-F5D5-63FD-C45D117854EE}" v="438" dt="2025-03-10T11:13:10.860"/>
-    <p1510:client id="{47A2E48A-311C-AC7E-B139-3FBF5D1DB6A3}" v="20" dt="2025-03-10T04:53:25.155"/>
-    <p1510:client id="{8C553AF1-1E71-8C34-AFE4-B59339B15FC4}" v="26" dt="2025-03-09T15:29:20.021"/>
+    <p1510:client id="{A5350847-2569-36D0-A15E-C9C2DE652C5B}" v="2" dt="2025-06-02T13:09:34.773"/>
+    <p1510:client id="{B7622861-D74E-29B0-1664-8BB351E1826D}" v="202" dt="2025-06-02T10:03:07.695"/>
   </p1510:revLst>
 </p1510:revInfo>
+</file>
+
+<file path=ppt/changesInfos/changesInfo1.xml><?xml version="1.0" encoding="utf-8"?>
+<pc:chgInfo xmlns:a="http://schemas.openxmlformats.org/drawingml/2006/main" xmlns:r="http://schemas.openxmlformats.org/officeDocument/2006/relationships" xmlns:ac="http://schemas.microsoft.com/office/drawing/2013/main/command" xmlns:pc="http://schemas.microsoft.com/office/powerpoint/2013/main/command">
+  <pc:docChgLst>
+    <pc:chgData name="Pranay Jagtap" userId="7f786bdeb347fddc" providerId="Windows Live" clId="Web-{B7622861-D74E-29B0-1664-8BB351E1826D}"/>
+    <pc:docChg chg="modSld">
+      <pc:chgData name="Pranay Jagtap" userId="7f786bdeb347fddc" providerId="Windows Live" clId="Web-{B7622861-D74E-29B0-1664-8BB351E1826D}" dt="2025-06-02T10:02:54.554" v="185"/>
+      <pc:docMkLst>
+        <pc:docMk/>
+      </pc:docMkLst>
+      <pc:sldChg chg="modSp">
+        <pc:chgData name="Pranay Jagtap" userId="7f786bdeb347fddc" providerId="Windows Live" clId="Web-{B7622861-D74E-29B0-1664-8BB351E1826D}" dt="2025-06-02T10:02:54.554" v="185"/>
+        <pc:sldMkLst>
+          <pc:docMk/>
+          <pc:sldMk cId="0" sldId="258"/>
+        </pc:sldMkLst>
+        <pc:spChg chg="mod">
+          <ac:chgData name="Pranay Jagtap" userId="7f786bdeb347fddc" providerId="Windows Live" clId="Web-{B7622861-D74E-29B0-1664-8BB351E1826D}" dt="2025-06-02T10:02:54.523" v="105"/>
+          <ac:spMkLst>
+            <pc:docMk/>
+            <pc:sldMk cId="0" sldId="258"/>
+            <ac:spMk id="3" creationId="{0B2A29C7-9720-41C7-95C7-B64349E57564}"/>
+          </ac:spMkLst>
+        </pc:spChg>
+        <pc:spChg chg="mod">
+          <ac:chgData name="Pranay Jagtap" userId="7f786bdeb347fddc" providerId="Windows Live" clId="Web-{B7622861-D74E-29B0-1664-8BB351E1826D}" dt="2025-06-02T10:02:54.523" v="104"/>
+          <ac:spMkLst>
+            <pc:docMk/>
+            <pc:sldMk cId="0" sldId="258"/>
+            <ac:spMk id="4" creationId="{54DCD9A4-39B9-9897-624E-FF44024B064D}"/>
+          </ac:spMkLst>
+        </pc:spChg>
+        <pc:spChg chg="mod">
+          <ac:chgData name="Pranay Jagtap" userId="7f786bdeb347fddc" providerId="Windows Live" clId="Web-{B7622861-D74E-29B0-1664-8BB351E1826D}" dt="2025-06-02T10:02:54.523" v="103"/>
+          <ac:spMkLst>
+            <pc:docMk/>
+            <pc:sldMk cId="0" sldId="258"/>
+            <ac:spMk id="5" creationId="{F5E530FF-1231-D568-D3C1-C0FC3CB7F7F9}"/>
+          </ac:spMkLst>
+        </pc:spChg>
+        <pc:spChg chg="mod">
+          <ac:chgData name="Pranay Jagtap" userId="7f786bdeb347fddc" providerId="Windows Live" clId="Web-{B7622861-D74E-29B0-1664-8BB351E1826D}" dt="2025-06-02T10:02:54.523" v="102"/>
+          <ac:spMkLst>
+            <pc:docMk/>
+            <pc:sldMk cId="0" sldId="258"/>
+            <ac:spMk id="6" creationId="{4320401B-D5A0-791C-94F8-AAACAA935F3A}"/>
+          </ac:spMkLst>
+        </pc:spChg>
+        <pc:spChg chg="mod">
+          <ac:chgData name="Pranay Jagtap" userId="7f786bdeb347fddc" providerId="Windows Live" clId="Web-{B7622861-D74E-29B0-1664-8BB351E1826D}" dt="2025-06-02T10:02:54.523" v="101"/>
+          <ac:spMkLst>
+            <pc:docMk/>
+            <pc:sldMk cId="0" sldId="258"/>
+            <ac:spMk id="8" creationId="{5E07F250-A97B-15D4-06BC-CDD275BC0E3D}"/>
+          </ac:spMkLst>
+        </pc:spChg>
+        <pc:spChg chg="mod">
+          <ac:chgData name="Pranay Jagtap" userId="7f786bdeb347fddc" providerId="Windows Live" clId="Web-{B7622861-D74E-29B0-1664-8BB351E1826D}" dt="2025-06-02T10:02:54.554" v="178"/>
+          <ac:spMkLst>
+            <pc:docMk/>
+            <pc:sldMk cId="0" sldId="258"/>
+            <ac:spMk id="9" creationId="{0691692C-638C-C4B1-57BD-A48A61B907BB}"/>
+          </ac:spMkLst>
+        </pc:spChg>
+        <pc:spChg chg="mod">
+          <ac:chgData name="Pranay Jagtap" userId="7f786bdeb347fddc" providerId="Windows Live" clId="Web-{B7622861-D74E-29B0-1664-8BB351E1826D}" dt="2025-06-02T10:02:54.523" v="100"/>
+          <ac:spMkLst>
+            <pc:docMk/>
+            <pc:sldMk cId="0" sldId="258"/>
+            <ac:spMk id="10" creationId="{813AD019-20E6-8AAA-8B78-5121A136BC20}"/>
+          </ac:spMkLst>
+        </pc:spChg>
+        <pc:spChg chg="mod">
+          <ac:chgData name="Pranay Jagtap" userId="7f786bdeb347fddc" providerId="Windows Live" clId="Web-{B7622861-D74E-29B0-1664-8BB351E1826D}" dt="2025-06-02T10:02:54.554" v="179"/>
+          <ac:spMkLst>
+            <pc:docMk/>
+            <pc:sldMk cId="0" sldId="258"/>
+            <ac:spMk id="14" creationId="{BB515267-A87E-7062-8DE3-5EF895B23A9A}"/>
+          </ac:spMkLst>
+        </pc:spChg>
+        <pc:spChg chg="mod">
+          <ac:chgData name="Pranay Jagtap" userId="7f786bdeb347fddc" providerId="Windows Live" clId="Web-{B7622861-D74E-29B0-1664-8BB351E1826D}" dt="2025-06-02T10:02:54.523" v="99"/>
+          <ac:spMkLst>
+            <pc:docMk/>
+            <pc:sldMk cId="0" sldId="258"/>
+            <ac:spMk id="15" creationId="{36694986-B1B1-0FF8-0447-80EC09104015}"/>
+          </ac:spMkLst>
+        </pc:spChg>
+        <pc:spChg chg="mod">
+          <ac:chgData name="Pranay Jagtap" userId="7f786bdeb347fddc" providerId="Windows Live" clId="Web-{B7622861-D74E-29B0-1664-8BB351E1826D}" dt="2025-06-02T10:02:54.523" v="98"/>
+          <ac:spMkLst>
+            <pc:docMk/>
+            <pc:sldMk cId="0" sldId="258"/>
+            <ac:spMk id="16" creationId="{51D02446-46C5-46DE-45A0-5AE36C2BA8A6}"/>
+          </ac:spMkLst>
+        </pc:spChg>
+        <pc:spChg chg="mod">
+          <ac:chgData name="Pranay Jagtap" userId="7f786bdeb347fddc" providerId="Windows Live" clId="Web-{B7622861-D74E-29B0-1664-8BB351E1826D}" dt="2025-06-02T10:02:54.554" v="180"/>
+          <ac:spMkLst>
+            <pc:docMk/>
+            <pc:sldMk cId="0" sldId="258"/>
+            <ac:spMk id="17" creationId="{3C23A133-B058-1658-848A-377A375CC9F0}"/>
+          </ac:spMkLst>
+        </pc:spChg>
+        <pc:spChg chg="mod">
+          <ac:chgData name="Pranay Jagtap" userId="7f786bdeb347fddc" providerId="Windows Live" clId="Web-{B7622861-D74E-29B0-1664-8BB351E1826D}" dt="2025-06-02T10:02:54.554" v="181"/>
+          <ac:spMkLst>
+            <pc:docMk/>
+            <pc:sldMk cId="0" sldId="258"/>
+            <ac:spMk id="18" creationId="{4702AC17-F9E1-E52C-EEFA-21188CE52C87}"/>
+          </ac:spMkLst>
+        </pc:spChg>
+        <pc:spChg chg="mod">
+          <ac:chgData name="Pranay Jagtap" userId="7f786bdeb347fddc" providerId="Windows Live" clId="Web-{B7622861-D74E-29B0-1664-8BB351E1826D}" dt="2025-06-02T10:02:54.554" v="182"/>
+          <ac:spMkLst>
+            <pc:docMk/>
+            <pc:sldMk cId="0" sldId="258"/>
+            <ac:spMk id="19" creationId="{0789832A-531A-D76F-80E4-D3C24708D089}"/>
+          </ac:spMkLst>
+        </pc:spChg>
+        <pc:spChg chg="mod">
+          <ac:chgData name="Pranay Jagtap" userId="7f786bdeb347fddc" providerId="Windows Live" clId="Web-{B7622861-D74E-29B0-1664-8BB351E1826D}" dt="2025-06-02T10:02:54.554" v="183"/>
+          <ac:spMkLst>
+            <pc:docMk/>
+            <pc:sldMk cId="0" sldId="258"/>
+            <ac:spMk id="20" creationId="{92D24C3D-9103-9D92-341B-EF91983F905E}"/>
+          </ac:spMkLst>
+        </pc:spChg>
+        <pc:spChg chg="mod">
+          <ac:chgData name="Pranay Jagtap" userId="7f786bdeb347fddc" providerId="Windows Live" clId="Web-{B7622861-D74E-29B0-1664-8BB351E1826D}" dt="2025-06-02T10:02:54.554" v="184"/>
+          <ac:spMkLst>
+            <pc:docMk/>
+            <pc:sldMk cId="0" sldId="258"/>
+            <ac:spMk id="21" creationId="{89DBCAAD-CFE7-A60C-800F-577C20B4B890}"/>
+          </ac:spMkLst>
+        </pc:spChg>
+        <pc:spChg chg="mod">
+          <ac:chgData name="Pranay Jagtap" userId="7f786bdeb347fddc" providerId="Windows Live" clId="Web-{B7622861-D74E-29B0-1664-8BB351E1826D}" dt="2025-06-02T10:02:54.523" v="97"/>
+          <ac:spMkLst>
+            <pc:docMk/>
+            <pc:sldMk cId="0" sldId="258"/>
+            <ac:spMk id="22" creationId="{C0464C74-3220-24B4-3B0E-95E6E3620B19}"/>
+          </ac:spMkLst>
+        </pc:spChg>
+        <pc:spChg chg="mod">
+          <ac:chgData name="Pranay Jagtap" userId="7f786bdeb347fddc" providerId="Windows Live" clId="Web-{B7622861-D74E-29B0-1664-8BB351E1826D}" dt="2025-06-02T10:02:54.523" v="96"/>
+          <ac:spMkLst>
+            <pc:docMk/>
+            <pc:sldMk cId="0" sldId="258"/>
+            <ac:spMk id="23" creationId="{BECB754B-6207-A85D-E98F-47F72B761892}"/>
+          </ac:spMkLst>
+        </pc:spChg>
+        <pc:spChg chg="mod">
+          <ac:chgData name="Pranay Jagtap" userId="7f786bdeb347fddc" providerId="Windows Live" clId="Web-{B7622861-D74E-29B0-1664-8BB351E1826D}" dt="2025-06-02T10:02:54.554" v="185"/>
+          <ac:spMkLst>
+            <pc:docMk/>
+            <pc:sldMk cId="0" sldId="258"/>
+            <ac:spMk id="26" creationId="{1A3B0FD1-0B41-ACB5-0BAC-163FFFB5979E}"/>
+          </ac:spMkLst>
+        </pc:spChg>
+        <pc:spChg chg="mod">
+          <ac:chgData name="Pranay Jagtap" userId="7f786bdeb347fddc" providerId="Windows Live" clId="Web-{B7622861-D74E-29B0-1664-8BB351E1826D}" dt="2025-06-02T10:02:54.554" v="177"/>
+          <ac:spMkLst>
+            <pc:docMk/>
+            <pc:sldMk cId="0" sldId="258"/>
+            <ac:spMk id="76" creationId="{00000000-0000-0000-0000-000000000000}"/>
+          </ac:spMkLst>
+        </pc:spChg>
+        <pc:spChg chg="mod">
+          <ac:chgData name="Pranay Jagtap" userId="7f786bdeb347fddc" providerId="Windows Live" clId="Web-{B7622861-D74E-29B0-1664-8BB351E1826D}" dt="2025-06-02T10:02:54.554" v="176"/>
+          <ac:spMkLst>
+            <pc:docMk/>
+            <pc:sldMk cId="0" sldId="258"/>
+            <ac:spMk id="77" creationId="{00000000-0000-0000-0000-000000000000}"/>
+          </ac:spMkLst>
+        </pc:spChg>
+        <pc:spChg chg="mod">
+          <ac:chgData name="Pranay Jagtap" userId="7f786bdeb347fddc" providerId="Windows Live" clId="Web-{B7622861-D74E-29B0-1664-8BB351E1826D}" dt="2025-06-02T10:02:54.554" v="175"/>
+          <ac:spMkLst>
+            <pc:docMk/>
+            <pc:sldMk cId="0" sldId="258"/>
+            <ac:spMk id="78" creationId="{00000000-0000-0000-0000-000000000000}"/>
+          </ac:spMkLst>
+        </pc:spChg>
+        <pc:spChg chg="mod">
+          <ac:chgData name="Pranay Jagtap" userId="7f786bdeb347fddc" providerId="Windows Live" clId="Web-{B7622861-D74E-29B0-1664-8BB351E1826D}" dt="2025-06-02T10:02:54.554" v="174"/>
+          <ac:spMkLst>
+            <pc:docMk/>
+            <pc:sldMk cId="0" sldId="258"/>
+            <ac:spMk id="79" creationId="{00000000-0000-0000-0000-000000000000}"/>
+          </ac:spMkLst>
+        </pc:spChg>
+        <pc:spChg chg="mod">
+          <ac:chgData name="Pranay Jagtap" userId="7f786bdeb347fddc" providerId="Windows Live" clId="Web-{B7622861-D74E-29B0-1664-8BB351E1826D}" dt="2025-06-02T10:02:54.554" v="173"/>
+          <ac:spMkLst>
+            <pc:docMk/>
+            <pc:sldMk cId="0" sldId="258"/>
+            <ac:spMk id="80" creationId="{00000000-0000-0000-0000-000000000000}"/>
+          </ac:spMkLst>
+        </pc:spChg>
+        <pc:spChg chg="mod">
+          <ac:chgData name="Pranay Jagtap" userId="7f786bdeb347fddc" providerId="Windows Live" clId="Web-{B7622861-D74E-29B0-1664-8BB351E1826D}" dt="2025-06-02T10:02:54.554" v="172"/>
+          <ac:spMkLst>
+            <pc:docMk/>
+            <pc:sldMk cId="0" sldId="258"/>
+            <ac:spMk id="81" creationId="{00000000-0000-0000-0000-000000000000}"/>
+          </ac:spMkLst>
+        </pc:spChg>
+        <pc:spChg chg="mod">
+          <ac:chgData name="Pranay Jagtap" userId="7f786bdeb347fddc" providerId="Windows Live" clId="Web-{B7622861-D74E-29B0-1664-8BB351E1826D}" dt="2025-06-02T10:02:54.554" v="171"/>
+          <ac:spMkLst>
+            <pc:docMk/>
+            <pc:sldMk cId="0" sldId="258"/>
+            <ac:spMk id="82" creationId="{00000000-0000-0000-0000-000000000000}"/>
+          </ac:spMkLst>
+        </pc:spChg>
+        <pc:spChg chg="mod">
+          <ac:chgData name="Pranay Jagtap" userId="7f786bdeb347fddc" providerId="Windows Live" clId="Web-{B7622861-D74E-29B0-1664-8BB351E1826D}" dt="2025-06-02T10:02:54.554" v="170"/>
+          <ac:spMkLst>
+            <pc:docMk/>
+            <pc:sldMk cId="0" sldId="258"/>
+            <ac:spMk id="84" creationId="{00000000-0000-0000-0000-000000000000}"/>
+          </ac:spMkLst>
+        </pc:spChg>
+        <pc:spChg chg="mod">
+          <ac:chgData name="Pranay Jagtap" userId="7f786bdeb347fddc" providerId="Windows Live" clId="Web-{B7622861-D74E-29B0-1664-8BB351E1826D}" dt="2025-06-02T10:02:54.554" v="169"/>
+          <ac:spMkLst>
+            <pc:docMk/>
+            <pc:sldMk cId="0" sldId="258"/>
+            <ac:spMk id="85" creationId="{00000000-0000-0000-0000-000000000000}"/>
+          </ac:spMkLst>
+        </pc:spChg>
+        <pc:spChg chg="mod">
+          <ac:chgData name="Pranay Jagtap" userId="7f786bdeb347fddc" providerId="Windows Live" clId="Web-{B7622861-D74E-29B0-1664-8BB351E1826D}" dt="2025-06-02T10:02:54.554" v="168"/>
+          <ac:spMkLst>
+            <pc:docMk/>
+            <pc:sldMk cId="0" sldId="258"/>
+            <ac:spMk id="87" creationId="{00000000-0000-0000-0000-000000000000}"/>
+          </ac:spMkLst>
+        </pc:spChg>
+        <pc:spChg chg="mod">
+          <ac:chgData name="Pranay Jagtap" userId="7f786bdeb347fddc" providerId="Windows Live" clId="Web-{B7622861-D74E-29B0-1664-8BB351E1826D}" dt="2025-06-02T10:02:54.554" v="167"/>
+          <ac:spMkLst>
+            <pc:docMk/>
+            <pc:sldMk cId="0" sldId="258"/>
+            <ac:spMk id="88" creationId="{00000000-0000-0000-0000-000000000000}"/>
+          </ac:spMkLst>
+        </pc:spChg>
+        <pc:spChg chg="mod">
+          <ac:chgData name="Pranay Jagtap" userId="7f786bdeb347fddc" providerId="Windows Live" clId="Web-{B7622861-D74E-29B0-1664-8BB351E1826D}" dt="2025-06-02T10:02:54.554" v="166"/>
+          <ac:spMkLst>
+            <pc:docMk/>
+            <pc:sldMk cId="0" sldId="258"/>
+            <ac:spMk id="91" creationId="{00000000-0000-0000-0000-000000000000}"/>
+          </ac:spMkLst>
+        </pc:spChg>
+        <pc:spChg chg="mod">
+          <ac:chgData name="Pranay Jagtap" userId="7f786bdeb347fddc" providerId="Windows Live" clId="Web-{B7622861-D74E-29B0-1664-8BB351E1826D}" dt="2025-06-02T10:02:54.554" v="165"/>
+          <ac:spMkLst>
+            <pc:docMk/>
+            <pc:sldMk cId="0" sldId="258"/>
+            <ac:spMk id="93" creationId="{00000000-0000-0000-0000-000000000000}"/>
+          </ac:spMkLst>
+        </pc:spChg>
+        <pc:spChg chg="mod">
+          <ac:chgData name="Pranay Jagtap" userId="7f786bdeb347fddc" providerId="Windows Live" clId="Web-{B7622861-D74E-29B0-1664-8BB351E1826D}" dt="2025-06-02T10:02:54.554" v="164"/>
+          <ac:spMkLst>
+            <pc:docMk/>
+            <pc:sldMk cId="0" sldId="258"/>
+            <ac:spMk id="94" creationId="{00000000-0000-0000-0000-000000000000}"/>
+          </ac:spMkLst>
+        </pc:spChg>
+        <pc:spChg chg="mod">
+          <ac:chgData name="Pranay Jagtap" userId="7f786bdeb347fddc" providerId="Windows Live" clId="Web-{B7622861-D74E-29B0-1664-8BB351E1826D}" dt="2025-06-02T10:02:54.554" v="163"/>
+          <ac:spMkLst>
+            <pc:docMk/>
+            <pc:sldMk cId="0" sldId="258"/>
+            <ac:spMk id="95" creationId="{00000000-0000-0000-0000-000000000000}"/>
+          </ac:spMkLst>
+        </pc:spChg>
+        <pc:spChg chg="mod">
+          <ac:chgData name="Pranay Jagtap" userId="7f786bdeb347fddc" providerId="Windows Live" clId="Web-{B7622861-D74E-29B0-1664-8BB351E1826D}" dt="2025-06-02T10:02:54.538" v="162"/>
+          <ac:spMkLst>
+            <pc:docMk/>
+            <pc:sldMk cId="0" sldId="258"/>
+            <ac:spMk id="96" creationId="{00000000-0000-0000-0000-000000000000}"/>
+          </ac:spMkLst>
+        </pc:spChg>
+        <pc:spChg chg="mod">
+          <ac:chgData name="Pranay Jagtap" userId="7f786bdeb347fddc" providerId="Windows Live" clId="Web-{B7622861-D74E-29B0-1664-8BB351E1826D}" dt="2025-06-02T10:02:54.538" v="161"/>
+          <ac:spMkLst>
+            <pc:docMk/>
+            <pc:sldMk cId="0" sldId="258"/>
+            <ac:spMk id="97" creationId="{00000000-0000-0000-0000-000000000000}"/>
+          </ac:spMkLst>
+        </pc:spChg>
+        <pc:spChg chg="mod">
+          <ac:chgData name="Pranay Jagtap" userId="7f786bdeb347fddc" providerId="Windows Live" clId="Web-{B7622861-D74E-29B0-1664-8BB351E1826D}" dt="2025-06-02T10:02:54.538" v="160"/>
+          <ac:spMkLst>
+            <pc:docMk/>
+            <pc:sldMk cId="0" sldId="258"/>
+            <ac:spMk id="98" creationId="{00000000-0000-0000-0000-000000000000}"/>
+          </ac:spMkLst>
+        </pc:spChg>
+        <pc:spChg chg="mod">
+          <ac:chgData name="Pranay Jagtap" userId="7f786bdeb347fddc" providerId="Windows Live" clId="Web-{B7622861-D74E-29B0-1664-8BB351E1826D}" dt="2025-06-02T10:02:54.538" v="159"/>
+          <ac:spMkLst>
+            <pc:docMk/>
+            <pc:sldMk cId="0" sldId="258"/>
+            <ac:spMk id="99" creationId="{00000000-0000-0000-0000-000000000000}"/>
+          </ac:spMkLst>
+        </pc:spChg>
+        <pc:spChg chg="mod">
+          <ac:chgData name="Pranay Jagtap" userId="7f786bdeb347fddc" providerId="Windows Live" clId="Web-{B7622861-D74E-29B0-1664-8BB351E1826D}" dt="2025-06-02T10:02:54.538" v="158"/>
+          <ac:spMkLst>
+            <pc:docMk/>
+            <pc:sldMk cId="0" sldId="258"/>
+            <ac:spMk id="100" creationId="{00000000-0000-0000-0000-000000000000}"/>
+          </ac:spMkLst>
+        </pc:spChg>
+        <pc:spChg chg="mod">
+          <ac:chgData name="Pranay Jagtap" userId="7f786bdeb347fddc" providerId="Windows Live" clId="Web-{B7622861-D74E-29B0-1664-8BB351E1826D}" dt="2025-06-02T10:02:54.538" v="157"/>
+          <ac:spMkLst>
+            <pc:docMk/>
+            <pc:sldMk cId="0" sldId="258"/>
+            <ac:spMk id="101" creationId="{00000000-0000-0000-0000-000000000000}"/>
+          </ac:spMkLst>
+        </pc:spChg>
+        <pc:spChg chg="mod">
+          <ac:chgData name="Pranay Jagtap" userId="7f786bdeb347fddc" providerId="Windows Live" clId="Web-{B7622861-D74E-29B0-1664-8BB351E1826D}" dt="2025-06-02T10:02:54.538" v="156"/>
+          <ac:spMkLst>
+            <pc:docMk/>
+            <pc:sldMk cId="0" sldId="258"/>
+            <ac:spMk id="102" creationId="{00000000-0000-0000-0000-000000000000}"/>
+          </ac:spMkLst>
+        </pc:spChg>
+        <pc:spChg chg="mod">
+          <ac:chgData name="Pranay Jagtap" userId="7f786bdeb347fddc" providerId="Windows Live" clId="Web-{B7622861-D74E-29B0-1664-8BB351E1826D}" dt="2025-06-02T10:02:54.538" v="155"/>
+          <ac:spMkLst>
+            <pc:docMk/>
+            <pc:sldMk cId="0" sldId="258"/>
+            <ac:spMk id="103" creationId="{00000000-0000-0000-0000-000000000000}"/>
+          </ac:spMkLst>
+        </pc:spChg>
+        <pc:spChg chg="mod">
+          <ac:chgData name="Pranay Jagtap" userId="7f786bdeb347fddc" providerId="Windows Live" clId="Web-{B7622861-D74E-29B0-1664-8BB351E1826D}" dt="2025-06-02T10:02:54.538" v="154"/>
+          <ac:spMkLst>
+            <pc:docMk/>
+            <pc:sldMk cId="0" sldId="258"/>
+            <ac:spMk id="104" creationId="{00000000-0000-0000-0000-000000000000}"/>
+          </ac:spMkLst>
+        </pc:spChg>
+        <pc:spChg chg="mod">
+          <ac:chgData name="Pranay Jagtap" userId="7f786bdeb347fddc" providerId="Windows Live" clId="Web-{B7622861-D74E-29B0-1664-8BB351E1826D}" dt="2025-06-02T10:02:54.538" v="153"/>
+          <ac:spMkLst>
+            <pc:docMk/>
+            <pc:sldMk cId="0" sldId="258"/>
+            <ac:spMk id="105" creationId="{00000000-0000-0000-0000-000000000000}"/>
+          </ac:spMkLst>
+        </pc:spChg>
+        <pc:spChg chg="mod">
+          <ac:chgData name="Pranay Jagtap" userId="7f786bdeb347fddc" providerId="Windows Live" clId="Web-{B7622861-D74E-29B0-1664-8BB351E1826D}" dt="2025-06-02T10:02:54.538" v="152"/>
+          <ac:spMkLst>
+            <pc:docMk/>
+            <pc:sldMk cId="0" sldId="258"/>
+            <ac:spMk id="106" creationId="{00000000-0000-0000-0000-000000000000}"/>
+          </ac:spMkLst>
+        </pc:spChg>
+        <pc:spChg chg="mod">
+          <ac:chgData name="Pranay Jagtap" userId="7f786bdeb347fddc" providerId="Windows Live" clId="Web-{B7622861-D74E-29B0-1664-8BB351E1826D}" dt="2025-06-02T10:02:54.538" v="151"/>
+          <ac:spMkLst>
+            <pc:docMk/>
+            <pc:sldMk cId="0" sldId="258"/>
+            <ac:spMk id="107" creationId="{00000000-0000-0000-0000-000000000000}"/>
+          </ac:spMkLst>
+        </pc:spChg>
+        <pc:spChg chg="mod">
+          <ac:chgData name="Pranay Jagtap" userId="7f786bdeb347fddc" providerId="Windows Live" clId="Web-{B7622861-D74E-29B0-1664-8BB351E1826D}" dt="2025-06-02T10:02:54.538" v="150"/>
+          <ac:spMkLst>
+            <pc:docMk/>
+            <pc:sldMk cId="0" sldId="258"/>
+            <ac:spMk id="108" creationId="{00000000-0000-0000-0000-000000000000}"/>
+          </ac:spMkLst>
+        </pc:spChg>
+        <pc:spChg chg="mod">
+          <ac:chgData name="Pranay Jagtap" userId="7f786bdeb347fddc" providerId="Windows Live" clId="Web-{B7622861-D74E-29B0-1664-8BB351E1826D}" dt="2025-06-02T10:02:54.538" v="149"/>
+          <ac:spMkLst>
+            <pc:docMk/>
+            <pc:sldMk cId="0" sldId="258"/>
+            <ac:spMk id="109" creationId="{00000000-0000-0000-0000-000000000000}"/>
+          </ac:spMkLst>
+        </pc:spChg>
+        <pc:spChg chg="mod">
+          <ac:chgData name="Pranay Jagtap" userId="7f786bdeb347fddc" providerId="Windows Live" clId="Web-{B7622861-D74E-29B0-1664-8BB351E1826D}" dt="2025-06-02T10:02:54.538" v="148"/>
+          <ac:spMkLst>
+            <pc:docMk/>
+            <pc:sldMk cId="0" sldId="258"/>
+            <ac:spMk id="110" creationId="{00000000-0000-0000-0000-000000000000}"/>
+          </ac:spMkLst>
+        </pc:spChg>
+        <pc:spChg chg="mod">
+          <ac:chgData name="Pranay Jagtap" userId="7f786bdeb347fddc" providerId="Windows Live" clId="Web-{B7622861-D74E-29B0-1664-8BB351E1826D}" dt="2025-06-02T10:02:54.538" v="147"/>
+          <ac:spMkLst>
+            <pc:docMk/>
+            <pc:sldMk cId="0" sldId="258"/>
+            <ac:spMk id="111" creationId="{00000000-0000-0000-0000-000000000000}"/>
+          </ac:spMkLst>
+        </pc:spChg>
+        <pc:spChg chg="mod">
+          <ac:chgData name="Pranay Jagtap" userId="7f786bdeb347fddc" providerId="Windows Live" clId="Web-{B7622861-D74E-29B0-1664-8BB351E1826D}" dt="2025-06-02T10:02:54.538" v="146"/>
+          <ac:spMkLst>
+            <pc:docMk/>
+            <pc:sldMk cId="0" sldId="258"/>
+            <ac:spMk id="112" creationId="{00000000-0000-0000-0000-000000000000}"/>
+          </ac:spMkLst>
+        </pc:spChg>
+        <pc:spChg chg="mod">
+          <ac:chgData name="Pranay Jagtap" userId="7f786bdeb347fddc" providerId="Windows Live" clId="Web-{B7622861-D74E-29B0-1664-8BB351E1826D}" dt="2025-06-02T10:02:54.538" v="145"/>
+          <ac:spMkLst>
+            <pc:docMk/>
+            <pc:sldMk cId="0" sldId="258"/>
+            <ac:spMk id="113" creationId="{00000000-0000-0000-0000-000000000000}"/>
+          </ac:spMkLst>
+        </pc:spChg>
+        <pc:spChg chg="mod">
+          <ac:chgData name="Pranay Jagtap" userId="7f786bdeb347fddc" providerId="Windows Live" clId="Web-{B7622861-D74E-29B0-1664-8BB351E1826D}" dt="2025-06-02T10:02:54.538" v="144"/>
+          <ac:spMkLst>
+            <pc:docMk/>
+            <pc:sldMk cId="0" sldId="258"/>
+            <ac:spMk id="114" creationId="{00000000-0000-0000-0000-000000000000}"/>
+          </ac:spMkLst>
+        </pc:spChg>
+        <pc:spChg chg="mod">
+          <ac:chgData name="Pranay Jagtap" userId="7f786bdeb347fddc" providerId="Windows Live" clId="Web-{B7622861-D74E-29B0-1664-8BB351E1826D}" dt="2025-06-02T10:02:54.538" v="143"/>
+          <ac:spMkLst>
+            <pc:docMk/>
+            <pc:sldMk cId="0" sldId="258"/>
+            <ac:spMk id="115" creationId="{00000000-0000-0000-0000-000000000000}"/>
+          </ac:spMkLst>
+        </pc:spChg>
+        <pc:spChg chg="mod">
+          <ac:chgData name="Pranay Jagtap" userId="7f786bdeb347fddc" providerId="Windows Live" clId="Web-{B7622861-D74E-29B0-1664-8BB351E1826D}" dt="2025-06-02T10:02:54.538" v="142"/>
+          <ac:spMkLst>
+            <pc:docMk/>
+            <pc:sldMk cId="0" sldId="258"/>
+            <ac:spMk id="116" creationId="{00000000-0000-0000-0000-000000000000}"/>
+          </ac:spMkLst>
+        </pc:spChg>
+        <pc:spChg chg="mod">
+          <ac:chgData name="Pranay Jagtap" userId="7f786bdeb347fddc" providerId="Windows Live" clId="Web-{B7622861-D74E-29B0-1664-8BB351E1826D}" dt="2025-06-02T10:02:54.538" v="141"/>
+          <ac:spMkLst>
+            <pc:docMk/>
+            <pc:sldMk cId="0" sldId="258"/>
+            <ac:spMk id="117" creationId="{00000000-0000-0000-0000-000000000000}"/>
+          </ac:spMkLst>
+        </pc:spChg>
+        <pc:spChg chg="mod">
+          <ac:chgData name="Pranay Jagtap" userId="7f786bdeb347fddc" providerId="Windows Live" clId="Web-{B7622861-D74E-29B0-1664-8BB351E1826D}" dt="2025-06-02T10:02:54.538" v="140"/>
+          <ac:spMkLst>
+            <pc:docMk/>
+            <pc:sldMk cId="0" sldId="258"/>
+            <ac:spMk id="118" creationId="{00000000-0000-0000-0000-000000000000}"/>
+          </ac:spMkLst>
+        </pc:spChg>
+        <pc:spChg chg="mod">
+          <ac:chgData name="Pranay Jagtap" userId="7f786bdeb347fddc" providerId="Windows Live" clId="Web-{B7622861-D74E-29B0-1664-8BB351E1826D}" dt="2025-06-02T10:02:54.538" v="139"/>
+          <ac:spMkLst>
+            <pc:docMk/>
+            <pc:sldMk cId="0" sldId="258"/>
+            <ac:spMk id="119" creationId="{00000000-0000-0000-0000-000000000000}"/>
+          </ac:spMkLst>
+        </pc:spChg>
+        <pc:spChg chg="mod">
+          <ac:chgData name="Pranay Jagtap" userId="7f786bdeb347fddc" providerId="Windows Live" clId="Web-{B7622861-D74E-29B0-1664-8BB351E1826D}" dt="2025-06-02T10:02:54.538" v="138"/>
+          <ac:spMkLst>
+            <pc:docMk/>
+            <pc:sldMk cId="0" sldId="258"/>
+            <ac:spMk id="120" creationId="{00000000-0000-0000-0000-000000000000}"/>
+          </ac:spMkLst>
+        </pc:spChg>
+        <pc:spChg chg="mod">
+          <ac:chgData name="Pranay Jagtap" userId="7f786bdeb347fddc" providerId="Windows Live" clId="Web-{B7622861-D74E-29B0-1664-8BB351E1826D}" dt="2025-06-02T10:02:54.538" v="137"/>
+          <ac:spMkLst>
+            <pc:docMk/>
+            <pc:sldMk cId="0" sldId="258"/>
+            <ac:spMk id="121" creationId="{00000000-0000-0000-0000-000000000000}"/>
+          </ac:spMkLst>
+        </pc:spChg>
+        <pc:spChg chg="mod">
+          <ac:chgData name="Pranay Jagtap" userId="7f786bdeb347fddc" providerId="Windows Live" clId="Web-{B7622861-D74E-29B0-1664-8BB351E1826D}" dt="2025-06-02T10:02:54.538" v="136"/>
+          <ac:spMkLst>
+            <pc:docMk/>
+            <pc:sldMk cId="0" sldId="258"/>
+            <ac:spMk id="122" creationId="{00000000-0000-0000-0000-000000000000}"/>
+          </ac:spMkLst>
+        </pc:spChg>
+        <pc:spChg chg="mod">
+          <ac:chgData name="Pranay Jagtap" userId="7f786bdeb347fddc" providerId="Windows Live" clId="Web-{B7622861-D74E-29B0-1664-8BB351E1826D}" dt="2025-06-02T10:02:54.538" v="135"/>
+          <ac:spMkLst>
+            <pc:docMk/>
+            <pc:sldMk cId="0" sldId="258"/>
+            <ac:spMk id="123" creationId="{00000000-0000-0000-0000-000000000000}"/>
+          </ac:spMkLst>
+        </pc:spChg>
+        <pc:spChg chg="mod">
+          <ac:chgData name="Pranay Jagtap" userId="7f786bdeb347fddc" providerId="Windows Live" clId="Web-{B7622861-D74E-29B0-1664-8BB351E1826D}" dt="2025-06-02T10:02:54.538" v="134"/>
+          <ac:spMkLst>
+            <pc:docMk/>
+            <pc:sldMk cId="0" sldId="258"/>
+            <ac:spMk id="124" creationId="{00000000-0000-0000-0000-000000000000}"/>
+          </ac:spMkLst>
+        </pc:spChg>
+        <pc:spChg chg="mod">
+          <ac:chgData name="Pranay Jagtap" userId="7f786bdeb347fddc" providerId="Windows Live" clId="Web-{B7622861-D74E-29B0-1664-8BB351E1826D}" dt="2025-06-02T10:02:54.538" v="133"/>
+          <ac:spMkLst>
+            <pc:docMk/>
+            <pc:sldMk cId="0" sldId="258"/>
+            <ac:spMk id="127" creationId="{00000000-0000-0000-0000-000000000000}"/>
+          </ac:spMkLst>
+        </pc:spChg>
+        <pc:spChg chg="mod">
+          <ac:chgData name="Pranay Jagtap" userId="7f786bdeb347fddc" providerId="Windows Live" clId="Web-{B7622861-D74E-29B0-1664-8BB351E1826D}" dt="2025-06-02T10:02:54.538" v="132"/>
+          <ac:spMkLst>
+            <pc:docMk/>
+            <pc:sldMk cId="0" sldId="258"/>
+            <ac:spMk id="128" creationId="{00000000-0000-0000-0000-000000000000}"/>
+          </ac:spMkLst>
+        </pc:spChg>
+        <pc:spChg chg="mod">
+          <ac:chgData name="Pranay Jagtap" userId="7f786bdeb347fddc" providerId="Windows Live" clId="Web-{B7622861-D74E-29B0-1664-8BB351E1826D}" dt="2025-06-02T10:02:54.538" v="131"/>
+          <ac:spMkLst>
+            <pc:docMk/>
+            <pc:sldMk cId="0" sldId="258"/>
+            <ac:spMk id="131" creationId="{00000000-0000-0000-0000-000000000000}"/>
+          </ac:spMkLst>
+        </pc:spChg>
+        <pc:spChg chg="mod">
+          <ac:chgData name="Pranay Jagtap" userId="7f786bdeb347fddc" providerId="Windows Live" clId="Web-{B7622861-D74E-29B0-1664-8BB351E1826D}" dt="2025-06-02T10:02:54.538" v="130"/>
+          <ac:spMkLst>
+            <pc:docMk/>
+            <pc:sldMk cId="0" sldId="258"/>
+            <ac:spMk id="132" creationId="{00000000-0000-0000-0000-000000000000}"/>
+          </ac:spMkLst>
+        </pc:spChg>
+        <pc:spChg chg="mod">
+          <ac:chgData name="Pranay Jagtap" userId="7f786bdeb347fddc" providerId="Windows Live" clId="Web-{B7622861-D74E-29B0-1664-8BB351E1826D}" dt="2025-06-02T10:02:54.538" v="129"/>
+          <ac:spMkLst>
+            <pc:docMk/>
+            <pc:sldMk cId="0" sldId="258"/>
+            <ac:spMk id="133" creationId="{00000000-0000-0000-0000-000000000000}"/>
+          </ac:spMkLst>
+        </pc:spChg>
+        <pc:spChg chg="mod">
+          <ac:chgData name="Pranay Jagtap" userId="7f786bdeb347fddc" providerId="Windows Live" clId="Web-{B7622861-D74E-29B0-1664-8BB351E1826D}" dt="2025-06-02T10:02:54.538" v="128"/>
+          <ac:spMkLst>
+            <pc:docMk/>
+            <pc:sldMk cId="0" sldId="258"/>
+            <ac:spMk id="134" creationId="{00000000-0000-0000-0000-000000000000}"/>
+          </ac:spMkLst>
+        </pc:spChg>
+        <pc:spChg chg="mod">
+          <ac:chgData name="Pranay Jagtap" userId="7f786bdeb347fddc" providerId="Windows Live" clId="Web-{B7622861-D74E-29B0-1664-8BB351E1826D}" dt="2025-06-02T10:02:54.538" v="127"/>
+          <ac:spMkLst>
+            <pc:docMk/>
+            <pc:sldMk cId="0" sldId="258"/>
+            <ac:spMk id="135" creationId="{00000000-0000-0000-0000-000000000000}"/>
+          </ac:spMkLst>
+        </pc:spChg>
+        <pc:spChg chg="mod">
+          <ac:chgData name="Pranay Jagtap" userId="7f786bdeb347fddc" providerId="Windows Live" clId="Web-{B7622861-D74E-29B0-1664-8BB351E1826D}" dt="2025-06-02T10:02:54.538" v="126"/>
+          <ac:spMkLst>
+            <pc:docMk/>
+            <pc:sldMk cId="0" sldId="258"/>
+            <ac:spMk id="136" creationId="{00000000-0000-0000-0000-000000000000}"/>
+          </ac:spMkLst>
+        </pc:spChg>
+        <pc:spChg chg="mod">
+          <ac:chgData name="Pranay Jagtap" userId="7f786bdeb347fddc" providerId="Windows Live" clId="Web-{B7622861-D74E-29B0-1664-8BB351E1826D}" dt="2025-06-02T10:02:54.538" v="125"/>
+          <ac:spMkLst>
+            <pc:docMk/>
+            <pc:sldMk cId="0" sldId="258"/>
+            <ac:spMk id="137" creationId="{00000000-0000-0000-0000-000000000000}"/>
+          </ac:spMkLst>
+        </pc:spChg>
+        <pc:spChg chg="mod">
+          <ac:chgData name="Pranay Jagtap" userId="7f786bdeb347fddc" providerId="Windows Live" clId="Web-{B7622861-D74E-29B0-1664-8BB351E1826D}" dt="2025-06-02T10:02:54.538" v="124"/>
+          <ac:spMkLst>
+            <pc:docMk/>
+            <pc:sldMk cId="0" sldId="258"/>
+            <ac:spMk id="138" creationId="{00000000-0000-0000-0000-000000000000}"/>
+          </ac:spMkLst>
+        </pc:spChg>
+        <pc:spChg chg="mod">
+          <ac:chgData name="Pranay Jagtap" userId="7f786bdeb347fddc" providerId="Windows Live" clId="Web-{B7622861-D74E-29B0-1664-8BB351E1826D}" dt="2025-06-02T10:02:54.538" v="123"/>
+          <ac:spMkLst>
+            <pc:docMk/>
+            <pc:sldMk cId="0" sldId="258"/>
+            <ac:spMk id="139" creationId="{00000000-0000-0000-0000-000000000000}"/>
+          </ac:spMkLst>
+        </pc:spChg>
+        <pc:spChg chg="mod">
+          <ac:chgData name="Pranay Jagtap" userId="7f786bdeb347fddc" providerId="Windows Live" clId="Web-{B7622861-D74E-29B0-1664-8BB351E1826D}" dt="2025-06-02T10:02:54.538" v="122"/>
+          <ac:spMkLst>
+            <pc:docMk/>
+            <pc:sldMk cId="0" sldId="258"/>
+            <ac:spMk id="140" creationId="{00000000-0000-0000-0000-000000000000}"/>
+          </ac:spMkLst>
+        </pc:spChg>
+        <pc:spChg chg="mod">
+          <ac:chgData name="Pranay Jagtap" userId="7f786bdeb347fddc" providerId="Windows Live" clId="Web-{B7622861-D74E-29B0-1664-8BB351E1826D}" dt="2025-06-02T10:02:54.538" v="121"/>
+          <ac:spMkLst>
+            <pc:docMk/>
+            <pc:sldMk cId="0" sldId="258"/>
+            <ac:spMk id="141" creationId="{00000000-0000-0000-0000-000000000000}"/>
+          </ac:spMkLst>
+        </pc:spChg>
+        <pc:spChg chg="mod">
+          <ac:chgData name="Pranay Jagtap" userId="7f786bdeb347fddc" providerId="Windows Live" clId="Web-{B7622861-D74E-29B0-1664-8BB351E1826D}" dt="2025-06-02T10:02:54.538" v="120"/>
+          <ac:spMkLst>
+            <pc:docMk/>
+            <pc:sldMk cId="0" sldId="258"/>
+            <ac:spMk id="142" creationId="{00000000-0000-0000-0000-000000000000}"/>
+          </ac:spMkLst>
+        </pc:spChg>
+        <pc:spChg chg="mod">
+          <ac:chgData name="Pranay Jagtap" userId="7f786bdeb347fddc" providerId="Windows Live" clId="Web-{B7622861-D74E-29B0-1664-8BB351E1826D}" dt="2025-06-02T10:02:54.538" v="119"/>
+          <ac:spMkLst>
+            <pc:docMk/>
+            <pc:sldMk cId="0" sldId="258"/>
+            <ac:spMk id="143" creationId="{00000000-0000-0000-0000-000000000000}"/>
+          </ac:spMkLst>
+        </pc:spChg>
+        <pc:spChg chg="mod">
+          <ac:chgData name="Pranay Jagtap" userId="7f786bdeb347fddc" providerId="Windows Live" clId="Web-{B7622861-D74E-29B0-1664-8BB351E1826D}" dt="2025-06-02T10:02:54.538" v="118"/>
+          <ac:spMkLst>
+            <pc:docMk/>
+            <pc:sldMk cId="0" sldId="258"/>
+            <ac:spMk id="144" creationId="{00000000-0000-0000-0000-000000000000}"/>
+          </ac:spMkLst>
+        </pc:spChg>
+        <pc:spChg chg="mod">
+          <ac:chgData name="Pranay Jagtap" userId="7f786bdeb347fddc" providerId="Windows Live" clId="Web-{B7622861-D74E-29B0-1664-8BB351E1826D}" dt="2025-06-02T10:02:54.538" v="117"/>
+          <ac:spMkLst>
+            <pc:docMk/>
+            <pc:sldMk cId="0" sldId="258"/>
+            <ac:spMk id="145" creationId="{00000000-0000-0000-0000-000000000000}"/>
+          </ac:spMkLst>
+        </pc:spChg>
+        <pc:spChg chg="mod">
+          <ac:chgData name="Pranay Jagtap" userId="7f786bdeb347fddc" providerId="Windows Live" clId="Web-{B7622861-D74E-29B0-1664-8BB351E1826D}" dt="2025-06-02T10:02:54.538" v="116"/>
+          <ac:spMkLst>
+            <pc:docMk/>
+            <pc:sldMk cId="0" sldId="258"/>
+            <ac:spMk id="146" creationId="{00000000-0000-0000-0000-000000000000}"/>
+          </ac:spMkLst>
+        </pc:spChg>
+        <pc:spChg chg="mod">
+          <ac:chgData name="Pranay Jagtap" userId="7f786bdeb347fddc" providerId="Windows Live" clId="Web-{B7622861-D74E-29B0-1664-8BB351E1826D}" dt="2025-06-02T10:02:54.538" v="115"/>
+          <ac:spMkLst>
+            <pc:docMk/>
+            <pc:sldMk cId="0" sldId="258"/>
+            <ac:spMk id="147" creationId="{00000000-0000-0000-0000-000000000000}"/>
+          </ac:spMkLst>
+        </pc:spChg>
+        <pc:spChg chg="mod">
+          <ac:chgData name="Pranay Jagtap" userId="7f786bdeb347fddc" providerId="Windows Live" clId="Web-{B7622861-D74E-29B0-1664-8BB351E1826D}" dt="2025-06-02T10:02:54.538" v="114"/>
+          <ac:spMkLst>
+            <pc:docMk/>
+            <pc:sldMk cId="0" sldId="258"/>
+            <ac:spMk id="148" creationId="{00000000-0000-0000-0000-000000000000}"/>
+          </ac:spMkLst>
+        </pc:spChg>
+        <pc:spChg chg="mod">
+          <ac:chgData name="Pranay Jagtap" userId="7f786bdeb347fddc" providerId="Windows Live" clId="Web-{B7622861-D74E-29B0-1664-8BB351E1826D}" dt="2025-06-02T10:02:54.538" v="113"/>
+          <ac:spMkLst>
+            <pc:docMk/>
+            <pc:sldMk cId="0" sldId="258"/>
+            <ac:spMk id="149" creationId="{00000000-0000-0000-0000-000000000000}"/>
+          </ac:spMkLst>
+        </pc:spChg>
+        <pc:spChg chg="mod">
+          <ac:chgData name="Pranay Jagtap" userId="7f786bdeb347fddc" providerId="Windows Live" clId="Web-{B7622861-D74E-29B0-1664-8BB351E1826D}" dt="2025-06-02T10:02:54.523" v="112"/>
+          <ac:spMkLst>
+            <pc:docMk/>
+            <pc:sldMk cId="0" sldId="258"/>
+            <ac:spMk id="150" creationId="{00000000-0000-0000-0000-000000000000}"/>
+          </ac:spMkLst>
+        </pc:spChg>
+        <pc:spChg chg="mod">
+          <ac:chgData name="Pranay Jagtap" userId="7f786bdeb347fddc" providerId="Windows Live" clId="Web-{B7622861-D74E-29B0-1664-8BB351E1826D}" dt="2025-06-02T10:02:54.523" v="111"/>
+          <ac:spMkLst>
+            <pc:docMk/>
+            <pc:sldMk cId="0" sldId="258"/>
+            <ac:spMk id="151" creationId="{00000000-0000-0000-0000-000000000000}"/>
+          </ac:spMkLst>
+        </pc:spChg>
+        <pc:spChg chg="mod">
+          <ac:chgData name="Pranay Jagtap" userId="7f786bdeb347fddc" providerId="Windows Live" clId="Web-{B7622861-D74E-29B0-1664-8BB351E1826D}" dt="2025-06-02T10:02:54.523" v="110"/>
+          <ac:spMkLst>
+            <pc:docMk/>
+            <pc:sldMk cId="0" sldId="258"/>
+            <ac:spMk id="152" creationId="{00000000-0000-0000-0000-000000000000}"/>
+          </ac:spMkLst>
+        </pc:spChg>
+        <pc:spChg chg="mod">
+          <ac:chgData name="Pranay Jagtap" userId="7f786bdeb347fddc" providerId="Windows Live" clId="Web-{B7622861-D74E-29B0-1664-8BB351E1826D}" dt="2025-06-02T10:02:54.523" v="109"/>
+          <ac:spMkLst>
+            <pc:docMk/>
+            <pc:sldMk cId="0" sldId="258"/>
+            <ac:spMk id="153" creationId="{00000000-0000-0000-0000-000000000000}"/>
+          </ac:spMkLst>
+        </pc:spChg>
+        <pc:spChg chg="mod">
+          <ac:chgData name="Pranay Jagtap" userId="7f786bdeb347fddc" providerId="Windows Live" clId="Web-{B7622861-D74E-29B0-1664-8BB351E1826D}" dt="2025-06-02T10:02:54.523" v="108"/>
+          <ac:spMkLst>
+            <pc:docMk/>
+            <pc:sldMk cId="0" sldId="258"/>
+            <ac:spMk id="154" creationId="{00000000-0000-0000-0000-000000000000}"/>
+          </ac:spMkLst>
+        </pc:spChg>
+        <pc:spChg chg="mod">
+          <ac:chgData name="Pranay Jagtap" userId="7f786bdeb347fddc" providerId="Windows Live" clId="Web-{B7622861-D74E-29B0-1664-8BB351E1826D}" dt="2025-06-02T10:02:54.523" v="107"/>
+          <ac:spMkLst>
+            <pc:docMk/>
+            <pc:sldMk cId="0" sldId="258"/>
+            <ac:spMk id="155" creationId="{00000000-0000-0000-0000-000000000000}"/>
+          </ac:spMkLst>
+        </pc:spChg>
+        <pc:spChg chg="mod">
+          <ac:chgData name="Pranay Jagtap" userId="7f786bdeb347fddc" providerId="Windows Live" clId="Web-{B7622861-D74E-29B0-1664-8BB351E1826D}" dt="2025-06-02T10:02:54.523" v="106"/>
+          <ac:spMkLst>
+            <pc:docMk/>
+            <pc:sldMk cId="0" sldId="258"/>
+            <ac:spMk id="156" creationId="{00000000-0000-0000-0000-000000000000}"/>
+          </ac:spMkLst>
+        </pc:spChg>
+      </pc:sldChg>
+    </pc:docChg>
+  </pc:docChgLst>
+  <pc:docChgLst>
+    <pc:chgData name="Pranay Jagtap" userId="7f786bdeb347fddc" providerId="Windows Live" clId="Web-{A5350847-2569-36D0-A15E-C9C2DE652C5B}"/>
+    <pc:docChg chg="modSld">
+      <pc:chgData name="Pranay Jagtap" userId="7f786bdeb347fddc" providerId="Windows Live" clId="Web-{A5350847-2569-36D0-A15E-C9C2DE652C5B}" dt="2025-06-02T13:09:34.773" v="1" actId="20577"/>
+      <pc:docMkLst>
+        <pc:docMk/>
+      </pc:docMkLst>
+      <pc:sldChg chg="modSp">
+        <pc:chgData name="Pranay Jagtap" userId="7f786bdeb347fddc" providerId="Windows Live" clId="Web-{A5350847-2569-36D0-A15E-C9C2DE652C5B}" dt="2025-06-02T13:09:34.773" v="1" actId="20577"/>
+        <pc:sldMkLst>
+          <pc:docMk/>
+          <pc:sldMk cId="0" sldId="258"/>
+        </pc:sldMkLst>
+        <pc:spChg chg="mod">
+          <ac:chgData name="Pranay Jagtap" userId="7f786bdeb347fddc" providerId="Windows Live" clId="Web-{A5350847-2569-36D0-A15E-C9C2DE652C5B}" dt="2025-06-02T13:09:34.773" v="1" actId="20577"/>
+          <ac:spMkLst>
+            <pc:docMk/>
+            <pc:sldMk cId="0" sldId="258"/>
+            <ac:spMk id="104" creationId="{00000000-0000-0000-0000-000000000000}"/>
+          </ac:spMkLst>
+        </pc:spChg>
+      </pc:sldChg>
+    </pc:docChg>
+  </pc:docChgLst>
+</pc:chgInfo>
 </file>
 
 <file path=ppt/notesMasters/notesMaster1.xml><?xml version="1.0" encoding="utf-8"?>
@@ -7334,7 +8097,7 @@
               <a:buNone/>
             </a:pPr>
             <a:r>
-              <a:rPr lang="en-US" sz="4400" b="1" u="none" strike="noStrike">
+              <a:rPr lang="en-US" sz="4400" b="1" u="none" strike="noStrike" dirty="0">
                 <a:solidFill>
                   <a:schemeClr val="dk1"/>
                 </a:solidFill>
@@ -7348,7 +8111,7 @@
               <a:rPr sz="4400"/>
             </a:br>
             <a:r>
-              <a:rPr lang="en-US" sz="4400" b="1" u="none" strike="noStrike">
+              <a:rPr lang="en-US" sz="4400" b="1" u="none" strike="noStrike" dirty="0">
                 <a:solidFill>
                   <a:schemeClr val="dk1"/>
                 </a:solidFill>
@@ -7362,7 +8125,7 @@
               <a:rPr sz="4400"/>
             </a:br>
             <a:r>
-              <a:rPr lang="en-US" sz="4400" b="1" u="none" strike="noStrike">
+              <a:rPr lang="en-US" sz="4400" b="1" u="none" strike="noStrike" dirty="0">
                 <a:solidFill>
                   <a:schemeClr val="dk1"/>
                 </a:solidFill>
@@ -7372,7 +8135,7 @@
               </a:rPr>
               <a:t>‘Machine Learning’</a:t>
             </a:r>
-            <a:endParaRPr lang="en-US" sz="4400" b="0" u="none" strike="noStrike">
+            <a:endParaRPr lang="en-US" sz="4400" b="0" u="none" strike="noStrike" dirty="0">
               <a:solidFill>
                 <a:schemeClr val="dk1"/>
               </a:solidFill>
@@ -8997,16 +9760,16 @@
               </a:tabLst>
             </a:pPr>
             <a:r>
-              <a:rPr lang="en-GB" b="1">
+              <a:rPr lang="en-GB" b="1" dirty="0">
                 <a:solidFill>
                   <a:srgbClr val="000000"/>
                 </a:solidFill>
                 <a:latin typeface="Calibri"/>
               </a:rPr>
-              <a:t>Deploy</a:t>
+              <a:t>Train &amp; Deploy</a:t>
             </a:r>
             <a:r>
-              <a:rPr lang="en-GB" sz="1800" b="1" u="none" strike="noStrike">
+              <a:rPr lang="en-GB" sz="1800" b="1" u="none" strike="noStrike" dirty="0">
                 <a:solidFill>
                   <a:srgbClr val="000000"/>
                 </a:solidFill>
@@ -9017,7 +9780,7 @@
               <a:t> a</a:t>
             </a:r>
             <a:r>
-              <a:rPr lang="en-GB" b="1">
+              <a:rPr lang="en-GB" b="1" dirty="0">
                 <a:solidFill>
                   <a:srgbClr val="000000"/>
                 </a:solidFill>
@@ -9025,7 +9788,7 @@
               </a:rPr>
               <a:t> </a:t>
             </a:r>
-            <a:endParaRPr lang="en-US">
+            <a:endParaRPr lang="en-US" dirty="0">
               <a:solidFill>
                 <a:srgbClr val="000000"/>
               </a:solidFill>
@@ -9036,18 +9799,12 @@
           </a:p>
           <a:p>
             <a:pPr algn="ctr" defTabSz="800280">
-              <a:lnSpc>
-                <a:spcPct val="90000"/>
-              </a:lnSpc>
-              <a:spcAft>
-                <a:spcPts val="839"/>
-              </a:spcAft>
               <a:tabLst>
                 <a:tab pos="0" algn="l"/>
               </a:tabLst>
             </a:pPr>
             <a:r>
-              <a:rPr lang="en-GB" sz="2400" b="1">
+              <a:rPr lang="en-GB" sz="2400" b="1" dirty="0">
                 <a:solidFill>
                   <a:srgbClr val="000000"/>
                 </a:solidFill>
@@ -9056,7 +9813,7 @@
               <a:t>'ML MODEL</a:t>
             </a:r>
             <a:r>
-              <a:rPr lang="en-GB" sz="2400" b="1" u="none" strike="noStrike">
+              <a:rPr lang="en-GB" sz="2400" b="1" u="none" strike="noStrike" dirty="0">
                 <a:solidFill>
                   <a:srgbClr val="000000"/>
                 </a:solidFill>
@@ -9066,7 +9823,7 @@
               </a:rPr>
               <a:t>’ </a:t>
             </a:r>
-            <a:endParaRPr lang="en-US" sz="2400" b="0" u="none" strike="noStrike">
+            <a:endParaRPr lang="en-US" sz="2400" b="0" u="none" strike="noStrike" dirty="0">
               <a:solidFill>
                 <a:srgbClr val="000000"/>
               </a:solidFill>
@@ -9098,29 +9855,27 @@
                 <a:uFillTx/>
                 <a:latin typeface="Calibri"/>
               </a:rPr>
-              <a:t>For career recommendation to </a:t>
+              <a:t>For career recommendation to college students</a:t>
             </a:r>
             <a:r>
-              <a:rPr lang="en-GB" sz="1800" b="1" u="none" strike="noStrike">
+              <a:rPr lang="en-GB" b="1" dirty="0">
                 <a:solidFill>
                   <a:srgbClr val="000000"/>
                 </a:solidFill>
-                <a:effectLst/>
-                <a:uFillTx/>
-                <a:latin typeface="Calibri"/>
-              </a:rPr>
-              <a:t>college students</a:t>
+                <a:latin typeface="Calibri"/>
+              </a:rPr>
+              <a:t> on </a:t>
             </a:r>
             <a:r>
-              <a:rPr lang="en-GB" b="1">
+              <a:rPr lang="en-GB" b="1" dirty="0" err="1">
                 <a:solidFill>
                   <a:srgbClr val="000000"/>
                 </a:solidFill>
                 <a:latin typeface="Calibri"/>
               </a:rPr>
-              <a:t> on Streamlit</a:t>
+              <a:t>Streamlit</a:t>
             </a:r>
-            <a:endParaRPr lang="en-US" sz="1800" b="0" u="none" strike="noStrike">
+            <a:endParaRPr lang="en-US" sz="1800" b="0" u="none" strike="noStrike" dirty="0" err="1">
               <a:solidFill>
                 <a:srgbClr val="000000"/>
               </a:solidFill>
@@ -9261,7 +10016,7 @@
               </a:tabLst>
             </a:pPr>
             <a:r>
-              <a:rPr lang="en-GB" sz="1200" b="1" u="none" strike="noStrike">
+              <a:rPr lang="en-GB" sz="1200" b="1" u="none" strike="noStrike" dirty="0">
                 <a:solidFill>
                   <a:srgbClr val="000000"/>
                 </a:solidFill>
@@ -9271,7 +10026,7 @@
               </a:rPr>
               <a:t>INITIATION</a:t>
             </a:r>
-            <a:endParaRPr lang="en-US" sz="1200" b="0" u="none" strike="noStrike">
+            <a:endParaRPr lang="en-US" sz="1200" b="0" u="none" strike="noStrike" dirty="0">
               <a:solidFill>
                 <a:srgbClr val="000000"/>
               </a:solidFill>
@@ -9412,7 +10167,7 @@
               </a:tabLst>
             </a:pPr>
             <a:r>
-              <a:rPr lang="en-GB" sz="1200" b="0" u="none" strike="noStrike">
+              <a:rPr lang="en-GB" sz="1200" b="0" u="none" strike="noStrike" dirty="0">
                 <a:solidFill>
                   <a:srgbClr val="000000"/>
                 </a:solidFill>
@@ -9422,7 +10177,7 @@
               </a:rPr>
               <a:t>Project Charter</a:t>
             </a:r>
-            <a:endParaRPr lang="en-US" sz="1200" b="0" u="none" strike="noStrike">
+            <a:endParaRPr lang="en-US" sz="1200" b="0" u="none" strike="noStrike" dirty="0">
               <a:solidFill>
                 <a:srgbClr val="000000"/>
               </a:solidFill>
@@ -9563,7 +10318,7 @@
               </a:tabLst>
             </a:pPr>
             <a:r>
-              <a:rPr lang="en-GB" sz="1200" b="0" u="none" strike="noStrike">
+              <a:rPr lang="en-GB" sz="1200" b="0" u="none" strike="noStrike" dirty="0">
                 <a:solidFill>
                   <a:srgbClr val="000000"/>
                 </a:solidFill>
@@ -9573,7 +10328,7 @@
               </a:rPr>
               <a:t>SRS Document</a:t>
             </a:r>
-            <a:endParaRPr lang="en-US" sz="1200" b="0" u="none" strike="noStrike">
+            <a:endParaRPr lang="en-US" sz="1200" b="0" u="none" strike="noStrike" dirty="0">
               <a:solidFill>
                 <a:srgbClr val="000000"/>
               </a:solidFill>
@@ -9714,7 +10469,7 @@
               </a:tabLst>
             </a:pPr>
             <a:r>
-              <a:rPr lang="en-GB" sz="1200" b="1" u="none" strike="noStrike">
+              <a:rPr lang="en-GB" sz="1200" b="1" u="none" strike="noStrike" dirty="0">
                 <a:solidFill>
                   <a:srgbClr val="000000"/>
                 </a:solidFill>
@@ -9724,7 +10479,7 @@
               </a:rPr>
               <a:t>PLANNING</a:t>
             </a:r>
-            <a:endParaRPr lang="en-US" sz="1200" b="0" u="none" strike="noStrike">
+            <a:endParaRPr lang="en-US" sz="1200" b="0" u="none" strike="noStrike" dirty="0">
               <a:solidFill>
                 <a:srgbClr val="000000"/>
               </a:solidFill>
@@ -9865,7 +10620,7 @@
               </a:tabLst>
             </a:pPr>
             <a:r>
-              <a:rPr lang="en-GB" sz="1200" b="0" u="none" strike="noStrike">
+              <a:rPr lang="en-GB" sz="1200" b="0" u="none" strike="noStrike" dirty="0">
                 <a:solidFill>
                   <a:srgbClr val="000000"/>
                 </a:solidFill>
@@ -9875,7 +10630,7 @@
               </a:rPr>
               <a:t>WBS</a:t>
             </a:r>
-            <a:endParaRPr lang="en-US" sz="1200" b="0" u="none" strike="noStrike">
+            <a:endParaRPr lang="en-US" sz="1200" b="0" u="none" strike="noStrike" dirty="0">
               <a:solidFill>
                 <a:srgbClr val="000000"/>
               </a:solidFill>
@@ -10016,7 +10771,7 @@
               </a:tabLst>
             </a:pPr>
             <a:r>
-              <a:rPr lang="en-GB" sz="1200" b="0" u="none" strike="noStrike">
+              <a:rPr lang="en-GB" sz="1200" b="0" u="none" strike="noStrike" dirty="0">
                 <a:solidFill>
                   <a:srgbClr val="000000"/>
                 </a:solidFill>
@@ -10026,7 +10781,7 @@
               </a:rPr>
               <a:t>Project Schedule</a:t>
             </a:r>
-            <a:endParaRPr lang="en-US" sz="1200" b="0" u="none" strike="noStrike">
+            <a:endParaRPr lang="en-US" sz="1200" b="0" u="none" strike="noStrike" dirty="0">
               <a:solidFill>
                 <a:srgbClr val="000000"/>
               </a:solidFill>
@@ -10167,7 +10922,7 @@
               </a:tabLst>
             </a:pPr>
             <a:r>
-              <a:rPr lang="en-GB" sz="1200" b="0" u="none" strike="noStrike">
+              <a:rPr lang="en-GB" sz="1200" b="0" u="none" strike="noStrike" dirty="0">
                 <a:solidFill>
                   <a:srgbClr val="000000"/>
                 </a:solidFill>
@@ -10177,7 +10932,7 @@
               </a:rPr>
               <a:t>RAID Logs</a:t>
             </a:r>
-            <a:endParaRPr lang="en-US" sz="1200" b="0" u="none" strike="noStrike">
+            <a:endParaRPr lang="en-US" sz="1200" b="0" u="none" strike="noStrike" dirty="0">
               <a:solidFill>
                 <a:srgbClr val="000000"/>
               </a:solidFill>
@@ -10318,7 +11073,7 @@
               </a:tabLst>
             </a:pPr>
             <a:r>
-              <a:rPr lang="en-GB" sz="1200" b="1" u="none" strike="noStrike">
+              <a:rPr lang="en-GB" sz="1200" b="1" u="none" strike="noStrike" dirty="0">
                 <a:solidFill>
                   <a:srgbClr val="000000"/>
                 </a:solidFill>
@@ -10328,7 +11083,7 @@
               </a:rPr>
               <a:t>EXECUTION &amp; MONITORING</a:t>
             </a:r>
-            <a:endParaRPr lang="en-US" sz="1200" b="0" u="none" strike="noStrike">
+            <a:endParaRPr lang="en-US" sz="1200" b="0" u="none" strike="noStrike" dirty="0">
               <a:solidFill>
                 <a:srgbClr val="000000"/>
               </a:solidFill>
@@ -10459,7 +11214,7 @@
               </a:tabLst>
             </a:pPr>
             <a:r>
-              <a:rPr lang="en-GB" sz="1200" b="0" u="none" strike="noStrike">
+              <a:rPr lang="en-GB" sz="1200" b="0" u="none" strike="noStrike" dirty="0">
                 <a:solidFill>
                   <a:srgbClr val="000000"/>
                 </a:solidFill>
@@ -10469,7 +11224,7 @@
               </a:rPr>
               <a:t>Data</a:t>
             </a:r>
-            <a:endParaRPr lang="en-US" sz="1200" b="0" u="none" strike="noStrike">
+            <a:endParaRPr lang="en-US" sz="1200" b="0" u="none" strike="noStrike" dirty="0">
               <a:solidFill>
                 <a:srgbClr val="000000"/>
               </a:solidFill>
@@ -10600,7 +11355,7 @@
               </a:tabLst>
             </a:pPr>
             <a:r>
-              <a:rPr lang="en-GB" sz="1200" b="0" u="none" strike="noStrike">
+              <a:rPr lang="en-GB" sz="1200" b="0" u="none" strike="noStrike" dirty="0">
                 <a:solidFill>
                   <a:srgbClr val="000000"/>
                 </a:solidFill>
@@ -10610,7 +11365,7 @@
               </a:rPr>
               <a:t>Data Collection</a:t>
             </a:r>
-            <a:endParaRPr lang="en-US" sz="1200" b="0" u="none" strike="noStrike">
+            <a:endParaRPr lang="en-US" sz="1200" b="0" u="none" strike="noStrike" dirty="0">
               <a:solidFill>
                 <a:srgbClr val="000000"/>
               </a:solidFill>
@@ -11021,7 +11776,7 @@
               </a:tabLst>
             </a:pPr>
             <a:r>
-              <a:rPr lang="en-GB" sz="1200" b="0" u="none" strike="noStrike">
+              <a:rPr lang="en-GB" sz="1200" b="0" u="none" strike="noStrike" dirty="0">
                 <a:solidFill>
                   <a:srgbClr val="000000"/>
                 </a:solidFill>
@@ -11031,7 +11786,7 @@
               </a:rPr>
               <a:t>Develop</a:t>
             </a:r>
-            <a:endParaRPr lang="en-US" sz="1200" b="0" u="none" strike="noStrike">
+            <a:endParaRPr lang="en-US" sz="1200" b="0" u="none" strike="noStrike" dirty="0">
               <a:solidFill>
                 <a:srgbClr val="000000"/>
               </a:solidFill>
@@ -11861,7 +12616,7 @@
               </a:tabLst>
             </a:pPr>
             <a:r>
-              <a:rPr lang="en-GB" sz="1200" b="0" u="none" strike="noStrike">
+              <a:rPr lang="en-GB" sz="1200" b="0" u="none" strike="noStrike" dirty="0">
                 <a:solidFill>
                   <a:srgbClr val="000000"/>
                 </a:solidFill>
@@ -11871,7 +12626,7 @@
               </a:rPr>
               <a:t>Test</a:t>
             </a:r>
-            <a:endParaRPr lang="en-US" sz="1200" b="0" u="none" strike="noStrike">
+            <a:endParaRPr lang="en-US" sz="1200" b="0" u="none" strike="noStrike" dirty="0">
               <a:solidFill>
                 <a:srgbClr val="000000"/>
               </a:solidFill>
@@ -12145,7 +12900,7 @@
               </a:tabLst>
             </a:pPr>
             <a:r>
-              <a:rPr lang="en-GB" sz="1200" b="0" u="none" strike="noStrike">
+              <a:rPr lang="en-GB" sz="1200" b="0" u="none" strike="noStrike" dirty="0">
                 <a:solidFill>
                   <a:srgbClr val="000000"/>
                 </a:solidFill>
@@ -12155,7 +12910,7 @@
               </a:rPr>
               <a:t>Deploy</a:t>
             </a:r>
-            <a:endParaRPr lang="en-US" sz="1200" b="0" u="none" strike="noStrike">
+            <a:endParaRPr lang="en-US" sz="1200" b="0" u="none" strike="noStrike" dirty="0">
               <a:solidFill>
                 <a:srgbClr val="000000"/>
               </a:solidFill>
@@ -12462,7 +13217,7 @@
               </a:tabLst>
             </a:pPr>
             <a:r>
-              <a:rPr lang="en-GB" sz="1200" b="1" u="none" strike="noStrike">
+              <a:rPr lang="en-GB" sz="1200" b="1" u="none" strike="noStrike" dirty="0">
                 <a:solidFill>
                   <a:srgbClr val="000000"/>
                 </a:solidFill>
@@ -12472,7 +13227,7 @@
               </a:rPr>
               <a:t>CLOSURE</a:t>
             </a:r>
-            <a:endParaRPr lang="en-US" sz="1200" b="0" u="none" strike="noStrike">
+            <a:endParaRPr lang="en-US" sz="1200" b="0" u="none" strike="noStrike" dirty="0">
               <a:solidFill>
                 <a:srgbClr val="000000"/>
               </a:solidFill>
@@ -12613,7 +13368,7 @@
               </a:tabLst>
             </a:pPr>
             <a:r>
-              <a:rPr lang="en-GB" sz="1200" b="0" u="none" strike="noStrike">
+              <a:rPr lang="en-GB" sz="1200" b="0" u="none" strike="noStrike" dirty="0">
                 <a:solidFill>
                   <a:srgbClr val="000000"/>
                 </a:solidFill>
@@ -12623,7 +13378,7 @@
               </a:rPr>
               <a:t>Lessons Learnt, Project Report</a:t>
             </a:r>
-            <a:endParaRPr lang="en-US" sz="1200" b="0" u="none" strike="noStrike">
+            <a:endParaRPr lang="en-US" sz="1200" b="0" u="none" strike="noStrike" dirty="0">
               <a:solidFill>
                 <a:srgbClr val="000000"/>
               </a:solidFill>

</xml_diff>